<commit_message>
docs: final-round deck polish for judging
Adds measured engine latency (1.87 ms avg) to metrics, one-line
mechanisms for sentiment handoff and interrupt handling, Freshcaller /
Freddy AI Agent compatibility, and moves the Hinglish ASR error figure
to Why Now.

Co-Authored-By: Claude Opus 5.5 <noreply@anthropic.com>
Claude-Session: https://claude.ai/code/session_012DT45KpxUQbVV43mbMd9KB
</commit_message>
<xml_diff>
--- a/docs/presentation/CodemixSkill-Final-Round.pptx
+++ b/docs/presentation/CodemixSkill-Final-Round.pptx
@@ -3362,7 +3362,7 @@
               <a:buNone/>
             </a:pPr>
             <a:r>
-              <a:rPr lang="en-US" sz="1350" i="1" dirty="0">
+              <a:rPr lang="en-US" sz="1300" i="1" dirty="0">
                 <a:solidFill>
                   <a:srgbClr val="5B6475"/>
                 </a:solidFill>
@@ -3370,9 +3370,9 @@
                 <a:ea typeface="Calibri" pitchFamily="34" charset="-122"/>
                 <a:cs typeface="Calibri" pitchFamily="34" charset="-120"/>
               </a:rPr>
-              <a:t>Freshdesk is where the AI hands over when it should not act alone</a:t>
-            </a:r>
-            <a:endParaRPr lang="en-US" sz="1350" dirty="0"/>
+              <a:t>Freshdesk takes the handoff; also works with Freshcaller as the voice channel and alongside Freddy AI Agent</a:t>
+            </a:r>
+            <a:endParaRPr lang="en-US" sz="1300" dirty="0"/>
           </a:p>
         </p:txBody>
       </p:sp>
@@ -5663,7 +5663,7 @@
                 <a:ea typeface="Calibri" pitchFamily="34" charset="-122"/>
                 <a:cs typeface="Calibri" pitchFamily="34" charset="-120"/>
               </a:rPr>
-              <a:t>Plugs in via an MCP / REST adapter around the agent's tool calls. The company keeps its existing agent and APIs.</a:t>
+              <a:t>Plugs in via an MCP / REST adapter around the agent's tool calls, whether that is Freddy AI Agent or the company's own agent. The company keeps its existing agent and APIs.</a:t>
             </a:r>
             <a:endParaRPr lang="en-US" sz="1200" dirty="0"/>
           </a:p>
@@ -12425,11 +12425,11 @@
         <p:spPr>
           <a:xfrm>
             <a:off x="548640" y="1920240"/>
-            <a:ext cx="6309360" cy="530352"/>
+            <a:ext cx="6309360" cy="457200"/>
           </a:xfrm>
           <a:prstGeom prst="roundRect">
             <a:avLst>
-              <a:gd name="adj" fmla="val 10345"/>
+              <a:gd name="adj" fmla="val 12000"/>
             </a:avLst>
           </a:prstGeom>
           <a:solidFill>
@@ -12452,7 +12452,7 @@
         <p:spPr>
           <a:xfrm>
             <a:off x="731520" y="1920240"/>
-            <a:ext cx="3017520" cy="530352"/>
+            <a:ext cx="3017520" cy="457200"/>
           </a:xfrm>
           <a:prstGeom prst="rect">
             <a:avLst/>
@@ -12468,7 +12468,7 @@
               <a:buNone/>
             </a:pPr>
             <a:r>
-              <a:rPr lang="en-US" sz="1250" b="1" dirty="0">
+              <a:rPr lang="en-US" sz="1200" b="1" dirty="0">
                 <a:solidFill>
                   <a:srgbClr val="14213D"/>
                 </a:solidFill>
@@ -12478,7 +12478,7 @@
               </a:rPr>
               <a:t>Wrong actions on negated requests</a:t>
             </a:r>
-            <a:endParaRPr lang="en-US" sz="1250" dirty="0"/>
+            <a:endParaRPr lang="en-US" sz="1200" dirty="0"/>
           </a:p>
         </p:txBody>
       </p:sp>
@@ -12491,7 +12491,7 @@
         <p:spPr>
           <a:xfrm>
             <a:off x="3749040" y="1920240"/>
-            <a:ext cx="1463040" cy="530352"/>
+            <a:ext cx="1463040" cy="457200"/>
           </a:xfrm>
           <a:prstGeom prst="rect">
             <a:avLst/>
@@ -12507,7 +12507,7 @@
               <a:buNone/>
             </a:pPr>
             <a:r>
-              <a:rPr lang="en-US" sz="1500" b="1" dirty="0">
+              <a:rPr lang="en-US" sz="1400" b="1" dirty="0">
                 <a:solidFill>
                   <a:srgbClr val="C8283C"/>
                 </a:solidFill>
@@ -12517,7 +12517,7 @@
               </a:rPr>
               <a:t>48%*</a:t>
             </a:r>
-            <a:endParaRPr lang="en-US" sz="1500" dirty="0"/>
+            <a:endParaRPr lang="en-US" sz="1400" dirty="0"/>
           </a:p>
         </p:txBody>
       </p:sp>
@@ -12530,7 +12530,7 @@
         <p:spPr>
           <a:xfrm>
             <a:off x="5303520" y="1920240"/>
-            <a:ext cx="1463040" cy="530352"/>
+            <a:ext cx="1463040" cy="457200"/>
           </a:xfrm>
           <a:prstGeom prst="rect">
             <a:avLst/>
@@ -12568,12 +12568,12 @@
         </p:nvSpPr>
         <p:spPr>
           <a:xfrm>
-            <a:off x="548640" y="2542032"/>
-            <a:ext cx="6309360" cy="530352"/>
+            <a:off x="548640" y="2450592"/>
+            <a:ext cx="6309360" cy="457200"/>
           </a:xfrm>
           <a:prstGeom prst="roundRect">
             <a:avLst>
-              <a:gd name="adj" fmla="val 10345"/>
+              <a:gd name="adj" fmla="val 12000"/>
             </a:avLst>
           </a:prstGeom>
           <a:solidFill>
@@ -12595,8 +12595,8 @@
         </p:nvSpPr>
         <p:spPr>
           <a:xfrm>
-            <a:off x="731520" y="2542032"/>
-            <a:ext cx="3017520" cy="530352"/>
+            <a:off x="731520" y="2450592"/>
+            <a:ext cx="3017520" cy="457200"/>
           </a:xfrm>
           <a:prstGeom prst="rect">
             <a:avLst/>
@@ -12612,7 +12612,7 @@
               <a:buNone/>
             </a:pPr>
             <a:r>
-              <a:rPr lang="en-US" sz="1250" b="1" dirty="0">
+              <a:rPr lang="en-US" sz="1200" b="1" dirty="0">
                 <a:solidFill>
                   <a:srgbClr val="14213D"/>
                 </a:solidFill>
@@ -12620,9 +12620,9 @@
                 <a:ea typeface="Calibri" pitchFamily="34" charset="-122"/>
                 <a:cs typeface="Calibri" pitchFamily="34" charset="-120"/>
               </a:rPr>
-              <a:t>p95 reply time (sensitive path)</a:t>
-            </a:r>
-            <a:endParaRPr lang="en-US" sz="1250" dirty="0"/>
+              <a:t>Engine latency (language + intent)</a:t>
+            </a:r>
+            <a:endParaRPr lang="en-US" sz="1200" dirty="0"/>
           </a:p>
         </p:txBody>
       </p:sp>
@@ -12634,8 +12634,8 @@
         </p:nvSpPr>
         <p:spPr>
           <a:xfrm>
-            <a:off x="3749040" y="2542032"/>
-            <a:ext cx="1463040" cy="530352"/>
+            <a:off x="3749040" y="2450592"/>
+            <a:ext cx="1463040" cy="457200"/>
           </a:xfrm>
           <a:prstGeom prst="rect">
             <a:avLst/>
@@ -12651,17 +12651,17 @@
               <a:buNone/>
             </a:pPr>
             <a:r>
-              <a:rPr lang="en-US" sz="1500" b="1" dirty="0">
-                <a:solidFill>
-                  <a:srgbClr val="B8C2D0"/>
-                </a:solidFill>
-                <a:latin typeface="Calibri" pitchFamily="34" charset="0"/>
-                <a:ea typeface="Calibri" pitchFamily="34" charset="-122"/>
-                <a:cs typeface="Calibri" pitchFamily="34" charset="-120"/>
-              </a:rPr>
-              <a:t>—</a:t>
-            </a:r>
-            <a:endParaRPr lang="en-US" sz="1500" dirty="0"/>
+              <a:rPr lang="en-US" sz="1400" b="1" dirty="0">
+                <a:solidFill>
+                  <a:srgbClr val="1F8A63"/>
+                </a:solidFill>
+                <a:latin typeface="Calibri" pitchFamily="34" charset="0"/>
+                <a:ea typeface="Calibri" pitchFamily="34" charset="-122"/>
+                <a:cs typeface="Calibri" pitchFamily="34" charset="-120"/>
+              </a:rPr>
+              <a:t>1.87 ms†</a:t>
+            </a:r>
+            <a:endParaRPr lang="en-US" sz="1400" dirty="0"/>
           </a:p>
         </p:txBody>
       </p:sp>
@@ -12673,8 +12673,8 @@
         </p:nvSpPr>
         <p:spPr>
           <a:xfrm>
-            <a:off x="5303520" y="2542032"/>
-            <a:ext cx="1463040" cy="530352"/>
+            <a:off x="5303520" y="2450592"/>
+            <a:ext cx="1463040" cy="457200"/>
           </a:xfrm>
           <a:prstGeom prst="rect">
             <a:avLst/>
@@ -12692,13 +12692,13 @@
             <a:r>
               <a:rPr lang="en-US" sz="1600" b="1" dirty="0">
                 <a:solidFill>
-                  <a:srgbClr val="14213D"/>
+                  <a:srgbClr val="1F8A63"/>
                 </a:solidFill>
                 <a:latin typeface="Cambria" pitchFamily="34" charset="0"/>
                 <a:ea typeface="Cambria" pitchFamily="34" charset="-122"/>
                 <a:cs typeface="Cambria" pitchFamily="34" charset="-120"/>
               </a:rPr>
-              <a:t>&lt; 900 ms</a:t>
+              <a:t>&lt; 5 ms</a:t>
             </a:r>
             <a:endParaRPr lang="en-US" sz="1600" dirty="0"/>
           </a:p>
@@ -12712,12 +12712,12 @@
         </p:nvSpPr>
         <p:spPr>
           <a:xfrm>
-            <a:off x="548640" y="3163824"/>
-            <a:ext cx="6309360" cy="530352"/>
+            <a:off x="548640" y="2980944"/>
+            <a:ext cx="6309360" cy="457200"/>
           </a:xfrm>
           <a:prstGeom prst="roundRect">
             <a:avLst>
-              <a:gd name="adj" fmla="val 10345"/>
+              <a:gd name="adj" fmla="val 12000"/>
             </a:avLst>
           </a:prstGeom>
           <a:solidFill>
@@ -12739,8 +12739,8 @@
         </p:nvSpPr>
         <p:spPr>
           <a:xfrm>
-            <a:off x="731520" y="3163824"/>
-            <a:ext cx="3017520" cy="530352"/>
+            <a:off x="731520" y="2980944"/>
+            <a:ext cx="3017520" cy="457200"/>
           </a:xfrm>
           <a:prstGeom prst="rect">
             <a:avLst/>
@@ -12756,7 +12756,7 @@
               <a:buNone/>
             </a:pPr>
             <a:r>
-              <a:rPr lang="en-US" sz="1250" b="1" dirty="0">
+              <a:rPr lang="en-US" sz="1200" b="1" dirty="0">
                 <a:solidFill>
                   <a:srgbClr val="14213D"/>
                 </a:solidFill>
@@ -12764,9 +12764,9 @@
                 <a:ea typeface="Calibri" pitchFamily="34" charset="-122"/>
                 <a:cs typeface="Calibri" pitchFamily="34" charset="-120"/>
               </a:rPr>
-              <a:t>Confirmation rate (friction budget)</a:t>
-            </a:r>
-            <a:endParaRPr lang="en-US" sz="1250" dirty="0"/>
+              <a:t>p95 reply time (sensitive path)</a:t>
+            </a:r>
+            <a:endParaRPr lang="en-US" sz="1200" dirty="0"/>
           </a:p>
         </p:txBody>
       </p:sp>
@@ -12778,8 +12778,8 @@
         </p:nvSpPr>
         <p:spPr>
           <a:xfrm>
-            <a:off x="3749040" y="3163824"/>
-            <a:ext cx="1463040" cy="530352"/>
+            <a:off x="3749040" y="2980944"/>
+            <a:ext cx="1463040" cy="457200"/>
           </a:xfrm>
           <a:prstGeom prst="rect">
             <a:avLst/>
@@ -12795,7 +12795,7 @@
               <a:buNone/>
             </a:pPr>
             <a:r>
-              <a:rPr lang="en-US" sz="1500" b="1" dirty="0">
+              <a:rPr lang="en-US" sz="1400" b="1" dirty="0">
                 <a:solidFill>
                   <a:srgbClr val="B8C2D0"/>
                 </a:solidFill>
@@ -12805,7 +12805,7 @@
               </a:rPr>
               <a:t>—</a:t>
             </a:r>
-            <a:endParaRPr lang="en-US" sz="1500" dirty="0"/>
+            <a:endParaRPr lang="en-US" sz="1400" dirty="0"/>
           </a:p>
         </p:txBody>
       </p:sp>
@@ -12817,8 +12817,8 @@
         </p:nvSpPr>
         <p:spPr>
           <a:xfrm>
-            <a:off x="5303520" y="3163824"/>
-            <a:ext cx="1463040" cy="530352"/>
+            <a:off x="5303520" y="2980944"/>
+            <a:ext cx="1463040" cy="457200"/>
           </a:xfrm>
           <a:prstGeom prst="rect">
             <a:avLst/>
@@ -12836,13 +12836,13 @@
             <a:r>
               <a:rPr lang="en-US" sz="1600" b="1" dirty="0">
                 <a:solidFill>
-                  <a:srgbClr val="7A5000"/>
+                  <a:srgbClr val="14213D"/>
                 </a:solidFill>
                 <a:latin typeface="Cambria" pitchFamily="34" charset="0"/>
                 <a:ea typeface="Cambria" pitchFamily="34" charset="-122"/>
                 <a:cs typeface="Cambria" pitchFamily="34" charset="-120"/>
               </a:rPr>
-              <a:t>≤ 15%</a:t>
+              <a:t>&lt; 900 ms</a:t>
             </a:r>
             <a:endParaRPr lang="en-US" sz="1600" dirty="0"/>
           </a:p>
@@ -12856,12 +12856,12 @@
         </p:nvSpPr>
         <p:spPr>
           <a:xfrm>
-            <a:off x="548640" y="3785616"/>
-            <a:ext cx="6309360" cy="530352"/>
+            <a:off x="548640" y="3511296"/>
+            <a:ext cx="6309360" cy="457200"/>
           </a:xfrm>
           <a:prstGeom prst="roundRect">
             <a:avLst>
-              <a:gd name="adj" fmla="val 10345"/>
+              <a:gd name="adj" fmla="val 12000"/>
             </a:avLst>
           </a:prstGeom>
           <a:solidFill>
@@ -12883,8 +12883,8 @@
         </p:nvSpPr>
         <p:spPr>
           <a:xfrm>
-            <a:off x="731520" y="3785616"/>
-            <a:ext cx="3017520" cy="530352"/>
+            <a:off x="731520" y="3511296"/>
+            <a:ext cx="3017520" cy="457200"/>
           </a:xfrm>
           <a:prstGeom prst="rect">
             <a:avLst/>
@@ -12900,7 +12900,7 @@
               <a:buNone/>
             </a:pPr>
             <a:r>
-              <a:rPr lang="en-US" sz="1250" b="1" dirty="0">
+              <a:rPr lang="en-US" sz="1200" b="1" dirty="0">
                 <a:solidFill>
                   <a:srgbClr val="14213D"/>
                 </a:solidFill>
@@ -12908,9 +12908,9 @@
                 <a:ea typeface="Calibri" pitchFamily="34" charset="-122"/>
                 <a:cs typeface="Calibri" pitchFamily="34" charset="-120"/>
               </a:rPr>
-              <a:t>Audit coverage</a:t>
-            </a:r>
-            <a:endParaRPr lang="en-US" sz="1250" dirty="0"/>
+              <a:t>Confirmation rate (friction budget)</a:t>
+            </a:r>
+            <a:endParaRPr lang="en-US" sz="1200" dirty="0"/>
           </a:p>
         </p:txBody>
       </p:sp>
@@ -12922,8 +12922,8 @@
         </p:nvSpPr>
         <p:spPr>
           <a:xfrm>
-            <a:off x="3749040" y="3785616"/>
-            <a:ext cx="1463040" cy="530352"/>
+            <a:off x="3749040" y="3511296"/>
+            <a:ext cx="1463040" cy="457200"/>
           </a:xfrm>
           <a:prstGeom prst="rect">
             <a:avLst/>
@@ -12939,7 +12939,7 @@
               <a:buNone/>
             </a:pPr>
             <a:r>
-              <a:rPr lang="en-US" sz="1500" b="1" dirty="0">
+              <a:rPr lang="en-US" sz="1400" b="1" dirty="0">
                 <a:solidFill>
                   <a:srgbClr val="B8C2D0"/>
                 </a:solidFill>
@@ -12949,7 +12949,7 @@
               </a:rPr>
               <a:t>—</a:t>
             </a:r>
-            <a:endParaRPr lang="en-US" sz="1500" dirty="0"/>
+            <a:endParaRPr lang="en-US" sz="1400" dirty="0"/>
           </a:p>
         </p:txBody>
       </p:sp>
@@ -12961,8 +12961,8 @@
         </p:nvSpPr>
         <p:spPr>
           <a:xfrm>
-            <a:off x="5303520" y="3785616"/>
-            <a:ext cx="1463040" cy="530352"/>
+            <a:off x="5303520" y="3511296"/>
+            <a:ext cx="1463040" cy="457200"/>
           </a:xfrm>
           <a:prstGeom prst="rect">
             <a:avLst/>
@@ -12980,13 +12980,13 @@
             <a:r>
               <a:rPr lang="en-US" sz="1600" b="1" dirty="0">
                 <a:solidFill>
-                  <a:srgbClr val="1F8A63"/>
+                  <a:srgbClr val="7A5000"/>
                 </a:solidFill>
                 <a:latin typeface="Cambria" pitchFamily="34" charset="0"/>
                 <a:ea typeface="Cambria" pitchFamily="34" charset="-122"/>
                 <a:cs typeface="Cambria" pitchFamily="34" charset="-120"/>
               </a:rPr>
-              <a:t>100%</a:t>
+              <a:t>≤ 15%</a:t>
             </a:r>
             <a:endParaRPr lang="en-US" sz="1600" dirty="0"/>
           </a:p>
@@ -13000,12 +13000,12 @@
         </p:nvSpPr>
         <p:spPr>
           <a:xfrm>
-            <a:off x="548640" y="4407408"/>
-            <a:ext cx="6309360" cy="530352"/>
+            <a:off x="548640" y="4041648"/>
+            <a:ext cx="6309360" cy="457200"/>
           </a:xfrm>
           <a:prstGeom prst="roundRect">
             <a:avLst>
-              <a:gd name="adj" fmla="val 10345"/>
+              <a:gd name="adj" fmla="val 12000"/>
             </a:avLst>
           </a:prstGeom>
           <a:solidFill>
@@ -13027,8 +13027,8 @@
         </p:nvSpPr>
         <p:spPr>
           <a:xfrm>
-            <a:off x="731520" y="4407408"/>
-            <a:ext cx="3017520" cy="530352"/>
+            <a:off x="731520" y="4041648"/>
+            <a:ext cx="3017520" cy="457200"/>
           </a:xfrm>
           <a:prstGeom prst="rect">
             <a:avLst/>
@@ -13044,7 +13044,7 @@
               <a:buNone/>
             </a:pPr>
             <a:r>
-              <a:rPr lang="en-US" sz="1250" b="1" dirty="0">
+              <a:rPr lang="en-US" sz="1200" b="1" dirty="0">
                 <a:solidFill>
                   <a:srgbClr val="14213D"/>
                 </a:solidFill>
@@ -13052,9 +13052,9 @@
                 <a:ea typeface="Calibri" pitchFamily="34" charset="-122"/>
                 <a:cs typeface="Calibri" pitchFamily="34" charset="-120"/>
               </a:rPr>
-              <a:t>Refund / cancel reversal tickets</a:t>
-            </a:r>
-            <a:endParaRPr lang="en-US" sz="1250" dirty="0"/>
+              <a:t>Audit coverage</a:t>
+            </a:r>
+            <a:endParaRPr lang="en-US" sz="1200" dirty="0"/>
           </a:p>
         </p:txBody>
       </p:sp>
@@ -13066,8 +13066,8 @@
         </p:nvSpPr>
         <p:spPr>
           <a:xfrm>
-            <a:off x="3749040" y="4407408"/>
-            <a:ext cx="1463040" cy="530352"/>
+            <a:off x="3749040" y="4041648"/>
+            <a:ext cx="1463040" cy="457200"/>
           </a:xfrm>
           <a:prstGeom prst="rect">
             <a:avLst/>
@@ -13083,7 +13083,7 @@
               <a:buNone/>
             </a:pPr>
             <a:r>
-              <a:rPr lang="en-US" sz="1500" b="1" dirty="0">
+              <a:rPr lang="en-US" sz="1400" b="1" dirty="0">
                 <a:solidFill>
                   <a:srgbClr val="B8C2D0"/>
                 </a:solidFill>
@@ -13093,7 +13093,7 @@
               </a:rPr>
               <a:t>—</a:t>
             </a:r>
-            <a:endParaRPr lang="en-US" sz="1500" dirty="0"/>
+            <a:endParaRPr lang="en-US" sz="1400" dirty="0"/>
           </a:p>
         </p:txBody>
       </p:sp>
@@ -13105,8 +13105,8 @@
         </p:nvSpPr>
         <p:spPr>
           <a:xfrm>
-            <a:off x="5303520" y="4407408"/>
-            <a:ext cx="1463040" cy="530352"/>
+            <a:off x="5303520" y="4041648"/>
+            <a:ext cx="1463040" cy="457200"/>
           </a:xfrm>
           <a:prstGeom prst="rect">
             <a:avLst/>
@@ -13130,7 +13130,7 @@
                 <a:ea typeface="Cambria" pitchFamily="34" charset="-122"/>
                 <a:cs typeface="Cambria" pitchFamily="34" charset="-120"/>
               </a:rPr>
-              <a:t>−30%</a:t>
+              <a:t>100%</a:t>
             </a:r>
             <a:endParaRPr lang="en-US" sz="1600" dirty="0"/>
           </a:p>
@@ -13144,12 +13144,12 @@
         </p:nvSpPr>
         <p:spPr>
           <a:xfrm>
-            <a:off x="548640" y="5029200"/>
-            <a:ext cx="6309360" cy="530352"/>
+            <a:off x="548640" y="4572000"/>
+            <a:ext cx="6309360" cy="457200"/>
           </a:xfrm>
           <a:prstGeom prst="roundRect">
             <a:avLst>
-              <a:gd name="adj" fmla="val 10345"/>
+              <a:gd name="adj" fmla="val 12000"/>
             </a:avLst>
           </a:prstGeom>
           <a:solidFill>
@@ -13171,8 +13171,8 @@
         </p:nvSpPr>
         <p:spPr>
           <a:xfrm>
-            <a:off x="731520" y="5029200"/>
-            <a:ext cx="3017520" cy="530352"/>
+            <a:off x="731520" y="4572000"/>
+            <a:ext cx="3017520" cy="457200"/>
           </a:xfrm>
           <a:prstGeom prst="rect">
             <a:avLst/>
@@ -13188,7 +13188,7 @@
               <a:buNone/>
             </a:pPr>
             <a:r>
-              <a:rPr lang="en-US" sz="1250" b="1" dirty="0">
+              <a:rPr lang="en-US" sz="1200" b="1" dirty="0">
                 <a:solidFill>
                   <a:srgbClr val="14213D"/>
                 </a:solidFill>
@@ -13196,9 +13196,9 @@
                 <a:ea typeface="Calibri" pitchFamily="34" charset="-122"/>
                 <a:cs typeface="Calibri" pitchFamily="34" charset="-120"/>
               </a:rPr>
-              <a:t>Adoption (eligible customers, 2 quarters)</a:t>
-            </a:r>
-            <a:endParaRPr lang="en-US" sz="1250" dirty="0"/>
+              <a:t>Refund / cancel reversal tickets</a:t>
+            </a:r>
+            <a:endParaRPr lang="en-US" sz="1200" dirty="0"/>
           </a:p>
         </p:txBody>
       </p:sp>
@@ -13210,8 +13210,8 @@
         </p:nvSpPr>
         <p:spPr>
           <a:xfrm>
-            <a:off x="3749040" y="5029200"/>
-            <a:ext cx="1463040" cy="530352"/>
+            <a:off x="3749040" y="4572000"/>
+            <a:ext cx="1463040" cy="457200"/>
           </a:xfrm>
           <a:prstGeom prst="rect">
             <a:avLst/>
@@ -13227,7 +13227,7 @@
               <a:buNone/>
             </a:pPr>
             <a:r>
-              <a:rPr lang="en-US" sz="1500" b="1" dirty="0">
+              <a:rPr lang="en-US" sz="1400" b="1" dirty="0">
                 <a:solidFill>
                   <a:srgbClr val="B8C2D0"/>
                 </a:solidFill>
@@ -13237,7 +13237,7 @@
               </a:rPr>
               <a:t>—</a:t>
             </a:r>
-            <a:endParaRPr lang="en-US" sz="1500" dirty="0"/>
+            <a:endParaRPr lang="en-US" sz="1400" dirty="0"/>
           </a:p>
         </p:txBody>
       </p:sp>
@@ -13249,8 +13249,8 @@
         </p:nvSpPr>
         <p:spPr>
           <a:xfrm>
-            <a:off x="5303520" y="5029200"/>
-            <a:ext cx="1463040" cy="530352"/>
+            <a:off x="5303520" y="4572000"/>
+            <a:ext cx="1463040" cy="457200"/>
           </a:xfrm>
           <a:prstGeom prst="rect">
             <a:avLst/>
@@ -13268,12 +13268,156 @@
             <a:r>
               <a:rPr lang="en-US" sz="1600" b="1" dirty="0">
                 <a:solidFill>
-                  <a:srgbClr val="2A5C8A"/>
+                  <a:srgbClr val="1F8A63"/>
                 </a:solidFill>
                 <a:latin typeface="Cambria" pitchFamily="34" charset="0"/>
                 <a:ea typeface="Cambria" pitchFamily="34" charset="-122"/>
                 <a:cs typeface="Cambria" pitchFamily="34" charset="-120"/>
               </a:rPr>
+              <a:t>−30%</a:t>
+            </a:r>
+            <a:endParaRPr lang="en-US" sz="1600" dirty="0"/>
+          </a:p>
+        </p:txBody>
+      </p:sp>
+      <p:sp>
+        <p:nvSpPr>
+          <p:cNvPr id="34" name="Shape 32"/>
+          <p:cNvSpPr/>
+          <p:nvPr/>
+        </p:nvSpPr>
+        <p:spPr>
+          <a:xfrm>
+            <a:off x="548640" y="5102352"/>
+            <a:ext cx="6309360" cy="457200"/>
+          </a:xfrm>
+          <a:prstGeom prst="roundRect">
+            <a:avLst>
+              <a:gd name="adj" fmla="val 12000"/>
+            </a:avLst>
+          </a:prstGeom>
+          <a:solidFill>
+            <a:srgbClr val="F4F6F9"/>
+          </a:solidFill>
+          <a:ln w="12700">
+            <a:solidFill>
+              <a:srgbClr val="F4F6F9"/>
+            </a:solidFill>
+            <a:prstDash val="solid"/>
+          </a:ln>
+        </p:spPr>
+      </p:sp>
+      <p:sp>
+        <p:nvSpPr>
+          <p:cNvPr id="35" name="Text 33"/>
+          <p:cNvSpPr txBox="1"/>
+          <p:nvPr/>
+        </p:nvSpPr>
+        <p:spPr>
+          <a:xfrm>
+            <a:off x="731520" y="5102352"/>
+            <a:ext cx="3017520" cy="457200"/>
+          </a:xfrm>
+          <a:prstGeom prst="rect">
+            <a:avLst/>
+          </a:prstGeom>
+          <a:noFill/>
+          <a:ln/>
+        </p:spPr>
+        <p:txBody>
+          <a:bodyPr wrap="square" lIns="0" tIns="0" rIns="0" bIns="0" rtlCol="0" anchor="ctr"/>
+          <a:lstStyle/>
+          <a:p>
+            <a:pPr indent="0" marL="0">
+              <a:buNone/>
+            </a:pPr>
+            <a:r>
+              <a:rPr lang="en-US" sz="1200" b="1" dirty="0">
+                <a:solidFill>
+                  <a:srgbClr val="14213D"/>
+                </a:solidFill>
+                <a:latin typeface="Calibri" pitchFamily="34" charset="0"/>
+                <a:ea typeface="Calibri" pitchFamily="34" charset="-122"/>
+                <a:cs typeface="Calibri" pitchFamily="34" charset="-120"/>
+              </a:rPr>
+              <a:t>Adoption (eligible customers, 2 quarters)</a:t>
+            </a:r>
+            <a:endParaRPr lang="en-US" sz="1200" dirty="0"/>
+          </a:p>
+        </p:txBody>
+      </p:sp>
+      <p:sp>
+        <p:nvSpPr>
+          <p:cNvPr id="36" name="Text 34"/>
+          <p:cNvSpPr txBox="1"/>
+          <p:nvPr/>
+        </p:nvSpPr>
+        <p:spPr>
+          <a:xfrm>
+            <a:off x="3749040" y="5102352"/>
+            <a:ext cx="1463040" cy="457200"/>
+          </a:xfrm>
+          <a:prstGeom prst="rect">
+            <a:avLst/>
+          </a:prstGeom>
+          <a:noFill/>
+          <a:ln/>
+        </p:spPr>
+        <p:txBody>
+          <a:bodyPr wrap="square" lIns="0" tIns="0" rIns="0" bIns="0" rtlCol="0" anchor="ctr"/>
+          <a:lstStyle/>
+          <a:p>
+            <a:pPr algn="ctr" indent="0" marL="0">
+              <a:buNone/>
+            </a:pPr>
+            <a:r>
+              <a:rPr lang="en-US" sz="1400" b="1" dirty="0">
+                <a:solidFill>
+                  <a:srgbClr val="B8C2D0"/>
+                </a:solidFill>
+                <a:latin typeface="Calibri" pitchFamily="34" charset="0"/>
+                <a:ea typeface="Calibri" pitchFamily="34" charset="-122"/>
+                <a:cs typeface="Calibri" pitchFamily="34" charset="-120"/>
+              </a:rPr>
+              <a:t>—</a:t>
+            </a:r>
+            <a:endParaRPr lang="en-US" sz="1400" dirty="0"/>
+          </a:p>
+        </p:txBody>
+      </p:sp>
+      <p:sp>
+        <p:nvSpPr>
+          <p:cNvPr id="37" name="Text 35"/>
+          <p:cNvSpPr txBox="1"/>
+          <p:nvPr/>
+        </p:nvSpPr>
+        <p:spPr>
+          <a:xfrm>
+            <a:off x="5303520" y="5102352"/>
+            <a:ext cx="1463040" cy="457200"/>
+          </a:xfrm>
+          <a:prstGeom prst="rect">
+            <a:avLst/>
+          </a:prstGeom>
+          <a:noFill/>
+          <a:ln/>
+        </p:spPr>
+        <p:txBody>
+          <a:bodyPr wrap="square" lIns="0" tIns="0" rIns="0" bIns="0" rtlCol="0" anchor="ctr"/>
+          <a:lstStyle/>
+          <a:p>
+            <a:pPr algn="ctr" indent="0" marL="0">
+              <a:buNone/>
+            </a:pPr>
+            <a:r>
+              <a:rPr lang="en-US" sz="1600" b="1" dirty="0">
+                <a:solidFill>
+                  <a:srgbClr val="2A5C8A"/>
+                </a:solidFill>
+                <a:latin typeface="Cambria" pitchFamily="34" charset="0"/>
+                <a:ea typeface="Cambria" pitchFamily="34" charset="-122"/>
+                <a:cs typeface="Cambria" pitchFamily="34" charset="-120"/>
+              </a:rPr>
               <a:t>15%</a:t>
             </a:r>
             <a:endParaRPr lang="en-US" sz="1600" dirty="0"/>
@@ -13282,14 +13426,14 @@
       </p:sp>
       <p:sp>
         <p:nvSpPr>
-          <p:cNvPr id="34" name="Text 32"/>
-          <p:cNvSpPr txBox="1"/>
-          <p:nvPr/>
-        </p:nvSpPr>
-        <p:spPr>
-          <a:xfrm>
-            <a:off x="548640" y="5715000"/>
-            <a:ext cx="6309360" cy="365760"/>
+          <p:cNvPr id="38" name="Text 36"/>
+          <p:cNvSpPr txBox="1"/>
+          <p:nvPr/>
+        </p:nvSpPr>
+        <p:spPr>
+          <a:xfrm>
+            <a:off x="548640" y="5669280"/>
+            <a:ext cx="6309360" cy="457200"/>
           </a:xfrm>
           <a:prstGeom prst="rect">
             <a:avLst/>
@@ -13313,7 +13457,7 @@
                 <a:ea typeface="Calibri" pitchFamily="34" charset="-122"/>
                 <a:cs typeface="Calibri" pitchFamily="34" charset="-120"/>
               </a:rPr>
-              <a:t>* Round-1 engine without the gate, on the 23-sentence negation test set.</a:t>
+              <a:t>* Round-1 engine without the gate, 23-sentence negation test set.   † Average over the repo benchmark (npm test), 0.12 ms median.</a:t>
             </a:r>
             <a:endParaRPr lang="en-US" sz="1000" dirty="0"/>
           </a:p>
@@ -13321,7 +13465,7 @@
       </p:sp>
       <p:sp>
         <p:nvSpPr>
-          <p:cNvPr id="35" name="Shape 33"/>
+          <p:cNvPr id="39" name="Shape 37"/>
           <p:cNvSpPr/>
           <p:nvPr/>
         </p:nvSpPr>
@@ -13355,7 +13499,7 @@
       </p:sp>
       <p:sp>
         <p:nvSpPr>
-          <p:cNvPr id="36" name="Text 34"/>
+          <p:cNvPr id="40" name="Text 38"/>
           <p:cNvSpPr txBox="1"/>
           <p:nvPr/>
         </p:nvSpPr>
@@ -13394,7 +13538,7 @@
       </p:sp>
       <p:sp>
         <p:nvSpPr>
-          <p:cNvPr id="37" name="Text 35"/>
+          <p:cNvPr id="41" name="Text 39"/>
           <p:cNvSpPr txBox="1"/>
           <p:nvPr/>
         </p:nvSpPr>
@@ -13441,7 +13585,7 @@
       </p:sp>
       <p:sp>
         <p:nvSpPr>
-          <p:cNvPr id="38" name="Shape 36"/>
+          <p:cNvPr id="42" name="Shape 40"/>
           <p:cNvSpPr/>
           <p:nvPr/>
         </p:nvSpPr>
@@ -13465,7 +13609,7 @@
       </p:sp>
       <p:sp>
         <p:nvSpPr>
-          <p:cNvPr id="39" name="Text 37"/>
+          <p:cNvPr id="43" name="Text 41"/>
           <p:cNvSpPr txBox="1"/>
           <p:nvPr/>
         </p:nvSpPr>
@@ -13527,7 +13671,7 @@
       </p:sp>
       <p:sp>
         <p:nvSpPr>
-          <p:cNvPr id="40" name="Shape 38"/>
+          <p:cNvPr id="44" name="Shape 42"/>
           <p:cNvSpPr/>
           <p:nvPr/>
         </p:nvSpPr>
@@ -13551,7 +13695,7 @@
       </p:sp>
       <p:sp>
         <p:nvSpPr>
-          <p:cNvPr id="41" name="Text 39"/>
+          <p:cNvPr id="45" name="Text 43"/>
           <p:cNvSpPr txBox="1"/>
           <p:nvPr/>
         </p:nvSpPr>
@@ -13590,7 +13734,7 @@
       </p:sp>
       <p:sp>
         <p:nvSpPr>
-          <p:cNvPr id="42" name="Shape 40"/>
+          <p:cNvPr id="46" name="Shape 44"/>
           <p:cNvSpPr/>
           <p:nvPr/>
         </p:nvSpPr>
@@ -13614,7 +13758,7 @@
       </p:sp>
       <p:sp>
         <p:nvSpPr>
-          <p:cNvPr id="43" name="Text 41"/>
+          <p:cNvPr id="47" name="Text 45"/>
           <p:cNvSpPr txBox="1"/>
           <p:nvPr/>
         </p:nvSpPr>
@@ -13653,7 +13797,7 @@
       </p:sp>
       <p:sp>
         <p:nvSpPr>
-          <p:cNvPr id="44" name="Text 42"/>
+          <p:cNvPr id="48" name="Text 46"/>
           <p:cNvSpPr txBox="1"/>
           <p:nvPr/>
         </p:nvSpPr>
@@ -13700,7 +13844,7 @@
       </p:sp>
       <p:sp>
         <p:nvSpPr>
-          <p:cNvPr id="45" name="Text 43"/>
+          <p:cNvPr id="49" name="Text 47"/>
           <p:cNvSpPr txBox="1"/>
           <p:nvPr/>
         </p:nvSpPr>
@@ -13764,7 +13908,7 @@
       </p:sp>
       <p:sp>
         <p:nvSpPr>
-          <p:cNvPr id="46" name="Text 44"/>
+          <p:cNvPr id="50" name="Text 48"/>
           <p:cNvSpPr txBox="1"/>
           <p:nvPr/>
         </p:nvSpPr>
@@ -13828,7 +13972,7 @@
       </p:sp>
       <p:sp>
         <p:nvSpPr>
-          <p:cNvPr id="47" name="Text 45"/>
+          <p:cNvPr id="51" name="Text 49"/>
           <p:cNvSpPr txBox="1"/>
           <p:nvPr/>
         </p:nvSpPr>
@@ -18079,7 +18223,7 @@
         <p:spPr>
           <a:xfrm>
             <a:off x="548640" y="4572000"/>
-            <a:ext cx="3520440" cy="1600200"/>
+            <a:ext cx="5440680" cy="1600200"/>
           </a:xfrm>
           <a:prstGeom prst="roundRect">
             <a:avLst>
@@ -18112,8 +18256,8 @@
         </p:nvSpPr>
         <p:spPr>
           <a:xfrm>
-            <a:off x="777240" y="4645152"/>
-            <a:ext cx="3108960" cy="548640"/>
+            <a:off x="777240" y="4663440"/>
+            <a:ext cx="1463040" cy="1097280"/>
           </a:xfrm>
           <a:prstGeom prst="rect">
             <a:avLst/>
@@ -18129,7 +18273,7 @@
               <a:buNone/>
             </a:pPr>
             <a:r>
-              <a:rPr lang="en-US" sz="2800" b="1" dirty="0">
+              <a:rPr lang="en-US" sz="3400" b="1" dirty="0">
                 <a:solidFill>
                   <a:srgbClr val="C8283C"/>
                 </a:solidFill>
@@ -18139,7 +18283,7 @@
               </a:rPr>
               <a:t>48%</a:t>
             </a:r>
-            <a:endParaRPr lang="en-US" sz="2800" dirty="0"/>
+            <a:endParaRPr lang="en-US" sz="3400" dirty="0"/>
           </a:p>
         </p:txBody>
       </p:sp>
@@ -18151,24 +18295,24 @@
         </p:nvSpPr>
         <p:spPr>
           <a:xfrm>
-            <a:off x="777240" y="5175504"/>
-            <a:ext cx="3108960" cy="566928"/>
-          </a:xfrm>
-          <a:prstGeom prst="rect">
-            <a:avLst/>
-          </a:prstGeom>
-          <a:noFill/>
-          <a:ln/>
-        </p:spPr>
-        <p:txBody>
-          <a:bodyPr wrap="square" lIns="0" tIns="0" rIns="0" bIns="0" rtlCol="0" anchor="t"/>
+            <a:off x="2331720" y="4681728"/>
+            <a:ext cx="3474720" cy="1051560"/>
+          </a:xfrm>
+          <a:prstGeom prst="rect">
+            <a:avLst/>
+          </a:prstGeom>
+          <a:noFill/>
+          <a:ln/>
+        </p:spPr>
+        <p:txBody>
+          <a:bodyPr wrap="square" lIns="0" tIns="0" rIns="0" bIns="0" rtlCol="0" anchor="ctr"/>
           <a:lstStyle/>
           <a:p>
             <a:pPr indent="0" marL="0">
               <a:buNone/>
             </a:pPr>
             <a:r>
-              <a:rPr lang="en-US" sz="1150" dirty="0">
+              <a:rPr lang="en-US" sz="1300" dirty="0">
                 <a:solidFill>
                   <a:srgbClr val="1F2937"/>
                 </a:solidFill>
@@ -18178,7 +18322,7 @@
               </a:rPr>
               <a:t>of negated requests would still trigger a refund / cancel in our own Round-1 engine</a:t>
             </a:r>
-            <a:endParaRPr lang="en-US" sz="1150" dirty="0"/>
+            <a:endParaRPr lang="en-US" sz="1300" dirty="0"/>
           </a:p>
         </p:txBody>
       </p:sp>
@@ -18229,8 +18373,8 @@
         </p:nvSpPr>
         <p:spPr>
           <a:xfrm>
-            <a:off x="4297680" y="4572000"/>
-            <a:ext cx="3520440" cy="1600200"/>
+            <a:off x="6217920" y="4572000"/>
+            <a:ext cx="5440680" cy="1600200"/>
           </a:xfrm>
           <a:prstGeom prst="roundRect">
             <a:avLst>
@@ -18263,8 +18407,8 @@
         </p:nvSpPr>
         <p:spPr>
           <a:xfrm>
-            <a:off x="4526280" y="4645152"/>
-            <a:ext cx="3108960" cy="548640"/>
+            <a:off x="6446520" y="4663440"/>
+            <a:ext cx="1463040" cy="1097280"/>
           </a:xfrm>
           <a:prstGeom prst="rect">
             <a:avLst/>
@@ -18280,17 +18424,17 @@
               <a:buNone/>
             </a:pPr>
             <a:r>
-              <a:rPr lang="en-US" sz="2800" b="1" dirty="0">
-                <a:solidFill>
-                  <a:srgbClr val="7A5000"/>
+              <a:rPr lang="en-US" sz="3400" b="1" dirty="0">
+                <a:solidFill>
+                  <a:srgbClr val="14213D"/>
                 </a:solidFill>
                 <a:latin typeface="Cambria" pitchFamily="34" charset="0"/>
                 <a:ea typeface="Cambria" pitchFamily="34" charset="-122"/>
                 <a:cs typeface="Cambria" pitchFamily="34" charset="-120"/>
               </a:rPr>
-              <a:t>27–70%</a:t>
-            </a:r>
-            <a:endParaRPr lang="en-US" sz="2800" dirty="0"/>
+              <a:t>26%</a:t>
+            </a:r>
+            <a:endParaRPr lang="en-US" sz="3400" dirty="0"/>
           </a:p>
         </p:txBody>
       </p:sp>
@@ -18302,8 +18446,47 @@
         </p:nvSpPr>
         <p:spPr>
           <a:xfrm>
-            <a:off x="4526280" y="5175504"/>
-            <a:ext cx="3108960" cy="566928"/>
+            <a:off x="8001000" y="4681728"/>
+            <a:ext cx="3474720" cy="1051560"/>
+          </a:xfrm>
+          <a:prstGeom prst="rect">
+            <a:avLst/>
+          </a:prstGeom>
+          <a:noFill/>
+          <a:ln/>
+        </p:spPr>
+        <p:txBody>
+          <a:bodyPr wrap="square" lIns="0" tIns="0" rIns="0" bIns="0" rtlCol="0" anchor="ctr"/>
+          <a:lstStyle/>
+          <a:p>
+            <a:pPr indent="0" marL="0">
+              <a:buNone/>
+            </a:pPr>
+            <a:r>
+              <a:rPr lang="en-US" sz="1300" dirty="0">
+                <a:solidFill>
+                  <a:srgbClr val="1F2937"/>
+                </a:solidFill>
+                <a:latin typeface="Calibri" pitchFamily="34" charset="0"/>
+                <a:ea typeface="Calibri" pitchFamily="34" charset="-122"/>
+                <a:cs typeface="Calibri" pitchFamily="34" charset="-120"/>
+              </a:rPr>
+              <a:t>of cash-on-delivery orders in India return to origin, so refund / cancel / return calls are high-volume</a:t>
+            </a:r>
+            <a:endParaRPr lang="en-US" sz="1300" dirty="0"/>
+          </a:p>
+        </p:txBody>
+      </p:sp>
+      <p:sp>
+        <p:nvSpPr>
+          <p:cNvPr id="30" name="Text 28"/>
+          <p:cNvSpPr txBox="1"/>
+          <p:nvPr/>
+        </p:nvSpPr>
+        <p:spPr>
+          <a:xfrm>
+            <a:off x="6446520" y="5760720"/>
+            <a:ext cx="3108960" cy="365760"/>
           </a:xfrm>
           <a:prstGeom prst="rect">
             <a:avLst/>
@@ -18319,45 +18502,6 @@
               <a:buNone/>
             </a:pPr>
             <a:r>
-              <a:rPr lang="en-US" sz="1150" dirty="0">
-                <a:solidFill>
-                  <a:srgbClr val="1F2937"/>
-                </a:solidFill>
-                <a:latin typeface="Calibri" pitchFamily="34" charset="0"/>
-                <a:ea typeface="Calibri" pitchFamily="34" charset="-122"/>
-                <a:cs typeface="Calibri" pitchFamily="34" charset="-120"/>
-              </a:rPr>
-              <a:t>word error rate on Hinglish across speech-to-text models, on identical audio</a:t>
-            </a:r>
-            <a:endParaRPr lang="en-US" sz="1150" dirty="0"/>
-          </a:p>
-        </p:txBody>
-      </p:sp>
-      <p:sp>
-        <p:nvSpPr>
-          <p:cNvPr id="30" name="Text 28"/>
-          <p:cNvSpPr txBox="1"/>
-          <p:nvPr/>
-        </p:nvSpPr>
-        <p:spPr>
-          <a:xfrm>
-            <a:off x="4526280" y="5760720"/>
-            <a:ext cx="3108960" cy="365760"/>
-          </a:xfrm>
-          <a:prstGeom prst="rect">
-            <a:avLst/>
-          </a:prstGeom>
-          <a:noFill/>
-          <a:ln/>
-        </p:spPr>
-        <p:txBody>
-          <a:bodyPr wrap="square" lIns="0" tIns="0" rIns="0" bIns="0" rtlCol="0" anchor="t"/>
-          <a:lstStyle/>
-          <a:p>
-            <a:pPr indent="0" marL="0">
-              <a:buNone/>
-            </a:pPr>
-            <a:r>
               <a:rPr lang="en-US" sz="900" i="1" dirty="0">
                 <a:solidFill>
                   <a:srgbClr val="5B6475"/>
@@ -18366,7 +18510,7 @@
                 <a:ea typeface="Calibri" pitchFamily="34" charset="-122"/>
                 <a:cs typeface="Calibri" pitchFamily="34" charset="-120"/>
               </a:rPr>
-              <a:t>Source: Deepgram, “Hinglish Voice AI: Why ASR Fails”</a:t>
+              <a:t>Source: Shipway ShipNotes report, FY25 (Jul 2025)</a:t>
             </a:r>
             <a:endParaRPr lang="en-US" sz="900" dirty="0"/>
           </a:p>
@@ -18374,158 +18518,7 @@
       </p:sp>
       <p:sp>
         <p:nvSpPr>
-          <p:cNvPr id="31" name="Shape 29"/>
-          <p:cNvSpPr/>
-          <p:nvPr/>
-        </p:nvSpPr>
-        <p:spPr>
-          <a:xfrm>
-            <a:off x="8046720" y="4572000"/>
-            <a:ext cx="3520440" cy="1600200"/>
-          </a:xfrm>
-          <a:prstGeom prst="roundRect">
-            <a:avLst>
-              <a:gd name="adj" fmla="val 5714"/>
-            </a:avLst>
-          </a:prstGeom>
-          <a:solidFill>
-            <a:srgbClr val="FFFFFF"/>
-          </a:solidFill>
-          <a:ln w="9525">
-            <a:solidFill>
-              <a:srgbClr val="DDE3EB"/>
-            </a:solidFill>
-            <a:prstDash val="solid"/>
-          </a:ln>
-          <a:effectLst>
-            <a:outerShdw sx="100000" sy="100000" kx="0" ky="0" algn="bl" rotWithShape="0" blurRad="76200" dist="25400" dir="5400000">
-              <a:srgbClr val="000000">
-                <a:alpha val="12000"/>
-              </a:srgbClr>
-            </a:outerShdw>
-          </a:effectLst>
-        </p:spPr>
-      </p:sp>
-      <p:sp>
-        <p:nvSpPr>
-          <p:cNvPr id="32" name="Text 30"/>
-          <p:cNvSpPr txBox="1"/>
-          <p:nvPr/>
-        </p:nvSpPr>
-        <p:spPr>
-          <a:xfrm>
-            <a:off x="8275320" y="4645152"/>
-            <a:ext cx="3108960" cy="548640"/>
-          </a:xfrm>
-          <a:prstGeom prst="rect">
-            <a:avLst/>
-          </a:prstGeom>
-          <a:noFill/>
-          <a:ln/>
-        </p:spPr>
-        <p:txBody>
-          <a:bodyPr wrap="square" lIns="0" tIns="0" rIns="0" bIns="0" rtlCol="0" anchor="ctr"/>
-          <a:lstStyle/>
-          <a:p>
-            <a:pPr indent="0" marL="0">
-              <a:buNone/>
-            </a:pPr>
-            <a:r>
-              <a:rPr lang="en-US" sz="2800" b="1" dirty="0">
-                <a:solidFill>
-                  <a:srgbClr val="14213D"/>
-                </a:solidFill>
-                <a:latin typeface="Cambria" pitchFamily="34" charset="0"/>
-                <a:ea typeface="Cambria" pitchFamily="34" charset="-122"/>
-                <a:cs typeface="Cambria" pitchFamily="34" charset="-120"/>
-              </a:rPr>
-              <a:t>26%</a:t>
-            </a:r>
-            <a:endParaRPr lang="en-US" sz="2800" dirty="0"/>
-          </a:p>
-        </p:txBody>
-      </p:sp>
-      <p:sp>
-        <p:nvSpPr>
-          <p:cNvPr id="33" name="Text 31"/>
-          <p:cNvSpPr txBox="1"/>
-          <p:nvPr/>
-        </p:nvSpPr>
-        <p:spPr>
-          <a:xfrm>
-            <a:off x="8275320" y="5175504"/>
-            <a:ext cx="3108960" cy="566928"/>
-          </a:xfrm>
-          <a:prstGeom prst="rect">
-            <a:avLst/>
-          </a:prstGeom>
-          <a:noFill/>
-          <a:ln/>
-        </p:spPr>
-        <p:txBody>
-          <a:bodyPr wrap="square" lIns="0" tIns="0" rIns="0" bIns="0" rtlCol="0" anchor="t"/>
-          <a:lstStyle/>
-          <a:p>
-            <a:pPr indent="0" marL="0">
-              <a:buNone/>
-            </a:pPr>
-            <a:r>
-              <a:rPr lang="en-US" sz="1150" dirty="0">
-                <a:solidFill>
-                  <a:srgbClr val="1F2937"/>
-                </a:solidFill>
-                <a:latin typeface="Calibri" pitchFamily="34" charset="0"/>
-                <a:ea typeface="Calibri" pitchFamily="34" charset="-122"/>
-                <a:cs typeface="Calibri" pitchFamily="34" charset="-120"/>
-              </a:rPr>
-              <a:t>of cash-on-delivery orders in India return to origin, so refund / cancel / return calls are high-volume</a:t>
-            </a:r>
-            <a:endParaRPr lang="en-US" sz="1150" dirty="0"/>
-          </a:p>
-        </p:txBody>
-      </p:sp>
-      <p:sp>
-        <p:nvSpPr>
-          <p:cNvPr id="34" name="Text 32"/>
-          <p:cNvSpPr txBox="1"/>
-          <p:nvPr/>
-        </p:nvSpPr>
-        <p:spPr>
-          <a:xfrm>
-            <a:off x="8275320" y="5760720"/>
-            <a:ext cx="3108960" cy="365760"/>
-          </a:xfrm>
-          <a:prstGeom prst="rect">
-            <a:avLst/>
-          </a:prstGeom>
-          <a:noFill/>
-          <a:ln/>
-        </p:spPr>
-        <p:txBody>
-          <a:bodyPr wrap="square" lIns="0" tIns="0" rIns="0" bIns="0" rtlCol="0" anchor="t"/>
-          <a:lstStyle/>
-          <a:p>
-            <a:pPr indent="0" marL="0">
-              <a:buNone/>
-            </a:pPr>
-            <a:r>
-              <a:rPr lang="en-US" sz="900" i="1" dirty="0">
-                <a:solidFill>
-                  <a:srgbClr val="5B6475"/>
-                </a:solidFill>
-                <a:latin typeface="Calibri" pitchFamily="34" charset="0"/>
-                <a:ea typeface="Calibri" pitchFamily="34" charset="-122"/>
-                <a:cs typeface="Calibri" pitchFamily="34" charset="-120"/>
-              </a:rPr>
-              <a:t>Source: Shipway ShipNotes report, FY25 (Jul 2025)</a:t>
-            </a:r>
-            <a:endParaRPr lang="en-US" sz="900" dirty="0"/>
-          </a:p>
-        </p:txBody>
-      </p:sp>
-      <p:sp>
-        <p:nvSpPr>
-          <p:cNvPr id="35" name="Text 33"/>
+          <p:cNvPr id="31" name="Text 29"/>
           <p:cNvSpPr txBox="1"/>
           <p:nvPr/>
         </p:nvSpPr>
@@ -18784,11 +18777,11 @@
         <p:spPr>
           <a:xfrm>
             <a:off x="548640" y="1600200"/>
-            <a:ext cx="3520440" cy="3108960"/>
+            <a:ext cx="3520440" cy="2697480"/>
           </a:xfrm>
           <a:prstGeom prst="roundRect">
             <a:avLst>
-              <a:gd name="adj" fmla="val 2941"/>
+              <a:gd name="adj" fmla="val 3390"/>
             </a:avLst>
           </a:prstGeom>
           <a:solidFill>
@@ -18817,8 +18810,8 @@
         </p:nvSpPr>
         <p:spPr>
           <a:xfrm>
-            <a:off x="822960" y="1828800"/>
-            <a:ext cx="777240" cy="777240"/>
+            <a:off x="822960" y="1783080"/>
+            <a:ext cx="640080" cy="640080"/>
           </a:xfrm>
           <a:prstGeom prst="ellipse">
             <a:avLst/>
@@ -18850,8 +18843,8 @@
         </p:blipFill>
         <p:spPr>
           <a:xfrm>
-            <a:off x="1009498" y="2015338"/>
-            <a:ext cx="404165" cy="404165"/>
+            <a:off x="976579" y="1936699"/>
+            <a:ext cx="332842" cy="332842"/>
           </a:xfrm>
           <a:prstGeom prst="rect">
             <a:avLst/>
@@ -18866,24 +18859,24 @@
         </p:nvSpPr>
         <p:spPr>
           <a:xfrm>
-            <a:off x="822960" y="2743200"/>
-            <a:ext cx="3017520" cy="411480"/>
-          </a:xfrm>
-          <a:prstGeom prst="rect">
-            <a:avLst/>
-          </a:prstGeom>
-          <a:noFill/>
-          <a:ln/>
-        </p:spPr>
-        <p:txBody>
-          <a:bodyPr wrap="square" lIns="0" tIns="0" rIns="0" bIns="0" rtlCol="0" anchor="t"/>
+            <a:off x="1600200" y="1783080"/>
+            <a:ext cx="2331720" cy="640080"/>
+          </a:xfrm>
+          <a:prstGeom prst="rect">
+            <a:avLst/>
+          </a:prstGeom>
+          <a:noFill/>
+          <a:ln/>
+        </p:spPr>
+        <p:txBody>
+          <a:bodyPr wrap="square" lIns="0" tIns="0" rIns="0" bIns="0" rtlCol="0" anchor="ctr"/>
           <a:lstStyle/>
           <a:p>
             <a:pPr indent="0" marL="0">
               <a:buNone/>
             </a:pPr>
             <a:r>
-              <a:rPr lang="en-US" sz="1800" b="1" dirty="0">
+              <a:rPr lang="en-US" sz="1700" b="1" dirty="0">
                 <a:solidFill>
                   <a:srgbClr val="14213D"/>
                 </a:solidFill>
@@ -18893,7 +18886,7 @@
               </a:rPr>
               <a:t>AI agents can act</a:t>
             </a:r>
-            <a:endParaRPr lang="en-US" sz="1800" dirty="0"/>
+            <a:endParaRPr lang="en-US" sz="1700" dirty="0"/>
           </a:p>
         </p:txBody>
       </p:sp>
@@ -18905,8 +18898,8 @@
         </p:nvSpPr>
         <p:spPr>
           <a:xfrm>
-            <a:off x="822960" y="3200400"/>
-            <a:ext cx="3017520" cy="1417320"/>
+            <a:off x="822960" y="2606040"/>
+            <a:ext cx="3017520" cy="1600200"/>
           </a:xfrm>
           <a:prstGeom prst="rect">
             <a:avLst/>
@@ -18945,11 +18938,11 @@
         <p:spPr>
           <a:xfrm>
             <a:off x="4297680" y="1600200"/>
-            <a:ext cx="3520440" cy="3108960"/>
+            <a:ext cx="3520440" cy="2697480"/>
           </a:xfrm>
           <a:prstGeom prst="roundRect">
             <a:avLst>
-              <a:gd name="adj" fmla="val 2941"/>
+              <a:gd name="adj" fmla="val 3390"/>
             </a:avLst>
           </a:prstGeom>
           <a:solidFill>
@@ -18978,8 +18971,8 @@
         </p:nvSpPr>
         <p:spPr>
           <a:xfrm>
-            <a:off x="4572000" y="1828800"/>
-            <a:ext cx="777240" cy="777240"/>
+            <a:off x="4572000" y="1783080"/>
+            <a:ext cx="640080" cy="640080"/>
           </a:xfrm>
           <a:prstGeom prst="ellipse">
             <a:avLst/>
@@ -19011,8 +19004,8 @@
         </p:blipFill>
         <p:spPr>
           <a:xfrm>
-            <a:off x="4758538" y="2015338"/>
-            <a:ext cx="404165" cy="404165"/>
+            <a:off x="4725619" y="1936699"/>
+            <a:ext cx="332842" cy="332842"/>
           </a:xfrm>
           <a:prstGeom prst="rect">
             <a:avLst/>
@@ -19027,24 +19020,24 @@
         </p:nvSpPr>
         <p:spPr>
           <a:xfrm>
-            <a:off x="4572000" y="2743200"/>
-            <a:ext cx="3017520" cy="411480"/>
-          </a:xfrm>
-          <a:prstGeom prst="rect">
-            <a:avLst/>
-          </a:prstGeom>
-          <a:noFill/>
-          <a:ln/>
-        </p:spPr>
-        <p:txBody>
-          <a:bodyPr wrap="square" lIns="0" tIns="0" rIns="0" bIns="0" rtlCol="0" anchor="t"/>
+            <a:off x="5349240" y="1783080"/>
+            <a:ext cx="2331720" cy="640080"/>
+          </a:xfrm>
+          <a:prstGeom prst="rect">
+            <a:avLst/>
+          </a:prstGeom>
+          <a:noFill/>
+          <a:ln/>
+        </p:spPr>
+        <p:txBody>
+          <a:bodyPr wrap="square" lIns="0" tIns="0" rIns="0" bIns="0" rtlCol="0" anchor="ctr"/>
           <a:lstStyle/>
           <a:p>
             <a:pPr indent="0" marL="0">
               <a:buNone/>
             </a:pPr>
             <a:r>
-              <a:rPr lang="en-US" sz="1800" b="1" dirty="0">
+              <a:rPr lang="en-US" sz="1700" b="1" dirty="0">
                 <a:solidFill>
                   <a:srgbClr val="14213D"/>
                 </a:solidFill>
@@ -19054,7 +19047,7 @@
               </a:rPr>
               <a:t>Code-mixing is normal</a:t>
             </a:r>
-            <a:endParaRPr lang="en-US" sz="1800" dirty="0"/>
+            <a:endParaRPr lang="en-US" sz="1700" dirty="0"/>
           </a:p>
         </p:txBody>
       </p:sp>
@@ -19066,8 +19059,8 @@
         </p:nvSpPr>
         <p:spPr>
           <a:xfrm>
-            <a:off x="4572000" y="3200400"/>
-            <a:ext cx="3017520" cy="1417320"/>
+            <a:off x="4572000" y="2606040"/>
+            <a:ext cx="3017520" cy="1600200"/>
           </a:xfrm>
           <a:prstGeom prst="rect">
             <a:avLst/>
@@ -19106,11 +19099,11 @@
         <p:spPr>
           <a:xfrm>
             <a:off x="8046720" y="1600200"/>
-            <a:ext cx="3520440" cy="3108960"/>
+            <a:ext cx="3520440" cy="2697480"/>
           </a:xfrm>
           <a:prstGeom prst="roundRect">
             <a:avLst>
-              <a:gd name="adj" fmla="val 2941"/>
+              <a:gd name="adj" fmla="val 3390"/>
             </a:avLst>
           </a:prstGeom>
           <a:solidFill>
@@ -19139,8 +19132,8 @@
         </p:nvSpPr>
         <p:spPr>
           <a:xfrm>
-            <a:off x="8321040" y="1828800"/>
-            <a:ext cx="777240" cy="777240"/>
+            <a:off x="8321040" y="1783080"/>
+            <a:ext cx="640080" cy="640080"/>
           </a:xfrm>
           <a:prstGeom prst="ellipse">
             <a:avLst/>
@@ -19172,8 +19165,8 @@
         </p:blipFill>
         <p:spPr>
           <a:xfrm>
-            <a:off x="8507578" y="2015338"/>
-            <a:ext cx="404165" cy="404165"/>
+            <a:off x="8474659" y="1936699"/>
+            <a:ext cx="332842" cy="332842"/>
           </a:xfrm>
           <a:prstGeom prst="rect">
             <a:avLst/>
@@ -19188,24 +19181,24 @@
         </p:nvSpPr>
         <p:spPr>
           <a:xfrm>
-            <a:off x="8321040" y="2743200"/>
-            <a:ext cx="3017520" cy="411480"/>
-          </a:xfrm>
-          <a:prstGeom prst="rect">
-            <a:avLst/>
-          </a:prstGeom>
-          <a:noFill/>
-          <a:ln/>
-        </p:spPr>
-        <p:txBody>
-          <a:bodyPr wrap="square" lIns="0" tIns="0" rIns="0" bIns="0" rtlCol="0" anchor="t"/>
+            <a:off x="9098280" y="1783080"/>
+            <a:ext cx="2331720" cy="640080"/>
+          </a:xfrm>
+          <a:prstGeom prst="rect">
+            <a:avLst/>
+          </a:prstGeom>
+          <a:noFill/>
+          <a:ln/>
+        </p:spPr>
+        <p:txBody>
+          <a:bodyPr wrap="square" lIns="0" tIns="0" rIns="0" bIns="0" rtlCol="0" anchor="ctr"/>
           <a:lstStyle/>
           <a:p>
             <a:pPr indent="0" marL="0">
               <a:buNone/>
             </a:pPr>
             <a:r>
-              <a:rPr lang="en-US" sz="1800" b="1" dirty="0">
+              <a:rPr lang="en-US" sz="1700" b="1" dirty="0">
                 <a:solidFill>
                   <a:srgbClr val="14213D"/>
                 </a:solidFill>
@@ -19215,7 +19208,7 @@
               </a:rPr>
               <a:t>Voice stack is ready</a:t>
             </a:r>
-            <a:endParaRPr lang="en-US" sz="1800" dirty="0"/>
+            <a:endParaRPr lang="en-US" sz="1700" dirty="0"/>
           </a:p>
         </p:txBody>
       </p:sp>
@@ -19227,8 +19220,8 @@
         </p:nvSpPr>
         <p:spPr>
           <a:xfrm>
-            <a:off x="8321040" y="3200400"/>
-            <a:ext cx="3017520" cy="1417320"/>
+            <a:off x="8321040" y="2606040"/>
+            <a:ext cx="3017520" cy="1600200"/>
           </a:xfrm>
           <a:prstGeom prst="rect">
             <a:avLst/>
@@ -19266,16 +19259,16 @@
         </p:nvSpPr>
         <p:spPr>
           <a:xfrm>
-            <a:off x="548640" y="4983480"/>
-            <a:ext cx="11064240" cy="1143000"/>
+            <a:off x="548640" y="4480560"/>
+            <a:ext cx="11064240" cy="868680"/>
           </a:xfrm>
           <a:prstGeom prst="roundRect">
             <a:avLst>
-              <a:gd name="adj" fmla="val 8000"/>
+              <a:gd name="adj" fmla="val 10526"/>
             </a:avLst>
           </a:prstGeom>
           <a:solidFill>
-            <a:srgbClr val="14213D"/>
+            <a:srgbClr val="FFF4DA"/>
           </a:solidFill>
           <a:ln w="9525">
             <a:solidFill>
@@ -19300,8 +19293,8 @@
         </p:nvSpPr>
         <p:spPr>
           <a:xfrm>
-            <a:off x="777240" y="4983480"/>
-            <a:ext cx="10607040" cy="1143000"/>
+            <a:off x="777240" y="4480560"/>
+            <a:ext cx="1828800" cy="868680"/>
           </a:xfrm>
           <a:prstGeom prst="rect">
             <a:avLst/>
@@ -19317,7 +19310,147 @@
               <a:buNone/>
             </a:pPr>
             <a:r>
-              <a:rPr lang="en-US" sz="1500" b="1" dirty="0">
+              <a:rPr lang="en-US" sz="3000" b="1" dirty="0">
+                <a:solidFill>
+                  <a:srgbClr val="7A5000"/>
+                </a:solidFill>
+                <a:latin typeface="Cambria" pitchFamily="34" charset="0"/>
+                <a:ea typeface="Cambria" pitchFamily="34" charset="-122"/>
+                <a:cs typeface="Cambria" pitchFamily="34" charset="-120"/>
+              </a:rPr>
+              <a:t>27–70%</a:t>
+            </a:r>
+            <a:endParaRPr lang="en-US" sz="3000" dirty="0"/>
+          </a:p>
+        </p:txBody>
+      </p:sp>
+      <p:sp>
+        <p:nvSpPr>
+          <p:cNvPr id="24" name="Text 19"/>
+          <p:cNvSpPr txBox="1"/>
+          <p:nvPr/>
+        </p:nvSpPr>
+        <p:spPr>
+          <a:xfrm>
+            <a:off x="2651760" y="4480560"/>
+            <a:ext cx="8778240" cy="868680"/>
+          </a:xfrm>
+          <a:prstGeom prst="rect">
+            <a:avLst/>
+          </a:prstGeom>
+          <a:noFill/>
+          <a:ln/>
+        </p:spPr>
+        <p:txBody>
+          <a:bodyPr wrap="square" lIns="0" tIns="0" rIns="0" bIns="0" rtlCol="0" anchor="ctr"/>
+          <a:lstStyle/>
+          <a:p>
+            <a:pPr indent="0" marL="0">
+              <a:buNone/>
+            </a:pPr>
+            <a:r>
+              <a:rPr lang="en-US" sz="1250" b="1" dirty="0">
+                <a:solidFill>
+                  <a:srgbClr val="14213D"/>
+                </a:solidFill>
+                <a:latin typeface="Calibri" pitchFamily="34" charset="0"/>
+                <a:ea typeface="Calibri" pitchFamily="34" charset="-122"/>
+                <a:cs typeface="Calibri" pitchFamily="34" charset="-120"/>
+              </a:rPr>
+              <a:t>word error rate on Hinglish across speech-to-text models, on identical audio. </a:t>
+            </a:r>
+            <a:pPr indent="0" marL="0">
+              <a:buNone/>
+            </a:pPr>
+            <a:r>
+              <a:rPr lang="en-US" sz="1250" dirty="0">
+                <a:solidFill>
+                  <a:srgbClr val="1F2937"/>
+                </a:solidFill>
+                <a:latin typeface="Calibri" pitchFamily="34" charset="0"/>
+                <a:ea typeface="Calibri" pitchFamily="34" charset="-122"/>
+                <a:cs typeface="Calibri" pitchFamily="34" charset="-120"/>
+              </a:rPr>
+              <a:t>Speech recognition alone can't yet be trusted with irreversible actions, so the gate is needed now.</a:t>
+            </a:r>
+            <a:pPr indent="0" marL="0">
+              <a:buNone/>
+            </a:pPr>
+            <a:r>
+              <a:rPr lang="en-US" sz="950" i="1" dirty="0">
+                <a:solidFill>
+                  <a:srgbClr val="5B6475"/>
+                </a:solidFill>
+                <a:latin typeface="Calibri" pitchFamily="34" charset="0"/>
+                <a:ea typeface="Calibri" pitchFamily="34" charset="-122"/>
+                <a:cs typeface="Calibri" pitchFamily="34" charset="-120"/>
+              </a:rPr>
+              <a:t>  Source: Deepgram, “Hinglish Voice AI: Why ASR Fails”</a:t>
+            </a:r>
+            <a:endParaRPr lang="en-US" sz="1250" dirty="0"/>
+          </a:p>
+        </p:txBody>
+      </p:sp>
+      <p:sp>
+        <p:nvSpPr>
+          <p:cNvPr id="25" name="Shape 20"/>
+          <p:cNvSpPr/>
+          <p:nvPr/>
+        </p:nvSpPr>
+        <p:spPr>
+          <a:xfrm>
+            <a:off x="548640" y="5532120"/>
+            <a:ext cx="11064240" cy="640080"/>
+          </a:xfrm>
+          <a:prstGeom prst="roundRect">
+            <a:avLst>
+              <a:gd name="adj" fmla="val 14286"/>
+            </a:avLst>
+          </a:prstGeom>
+          <a:solidFill>
+            <a:srgbClr val="14213D"/>
+          </a:solidFill>
+          <a:ln w="9525">
+            <a:solidFill>
+              <a:srgbClr val="DDE3EB"/>
+            </a:solidFill>
+            <a:prstDash val="solid"/>
+          </a:ln>
+          <a:effectLst>
+            <a:outerShdw sx="100000" sy="100000" kx="0" ky="0" algn="bl" rotWithShape="0" blurRad="76200" dist="25400" dir="5400000">
+              <a:srgbClr val="000000">
+                <a:alpha val="12000"/>
+              </a:srgbClr>
+            </a:outerShdw>
+          </a:effectLst>
+        </p:spPr>
+      </p:sp>
+      <p:sp>
+        <p:nvSpPr>
+          <p:cNvPr id="26" name="Text 21"/>
+          <p:cNvSpPr txBox="1"/>
+          <p:nvPr/>
+        </p:nvSpPr>
+        <p:spPr>
+          <a:xfrm>
+            <a:off x="777240" y="5532120"/>
+            <a:ext cx="10607040" cy="640080"/>
+          </a:xfrm>
+          <a:prstGeom prst="rect">
+            <a:avLst/>
+          </a:prstGeom>
+          <a:noFill/>
+          <a:ln/>
+        </p:spPr>
+        <p:txBody>
+          <a:bodyPr wrap="square" lIns="0" tIns="0" rIns="0" bIns="0" rtlCol="0" anchor="ctr"/>
+          <a:lstStyle/>
+          <a:p>
+            <a:pPr indent="0" marL="0">
+              <a:buNone/>
+            </a:pPr>
+            <a:r>
+              <a:rPr lang="en-US" sz="1300" b="1" dirty="0">
                 <a:solidFill>
                   <a:srgbClr val="F4A300"/>
                 </a:solidFill>
@@ -19331,7 +19464,7 @@
               <a:buNone/>
             </a:pPr>
             <a:r>
-              <a:rPr lang="en-US" sz="1500" dirty="0">
+              <a:rPr lang="en-US" sz="1300" dirty="0">
                 <a:solidFill>
                   <a:srgbClr val="FFFFFF"/>
                 </a:solidFill>
@@ -19341,13 +19474,13 @@
               </a:rPr>
               <a:t>The missing layer is not another voice bot. It is a safety and decision layer that controls when an existing AI agent is allowed to call an API.</a:t>
             </a:r>
-            <a:endParaRPr lang="en-US" sz="1500" dirty="0"/>
-          </a:p>
-        </p:txBody>
-      </p:sp>
-      <p:sp>
-        <p:nvSpPr>
-          <p:cNvPr id="24" name="Text 19"/>
+            <a:endParaRPr lang="en-US" sz="1300" dirty="0"/>
+          </a:p>
+        </p:txBody>
+      </p:sp>
+      <p:sp>
+        <p:nvSpPr>
+          <p:cNvPr id="27" name="Text 22"/>
           <p:cNvSpPr txBox="1"/>
           <p:nvPr/>
         </p:nvSpPr>
@@ -26304,8 +26437,8 @@
         </p:nvSpPr>
         <p:spPr>
           <a:xfrm>
-            <a:off x="548640" y="5669280"/>
-            <a:ext cx="11109960" cy="457200"/>
+            <a:off x="548640" y="5577840"/>
+            <a:ext cx="11109960" cy="594360"/>
           </a:xfrm>
           <a:prstGeom prst="rect">
             <a:avLst/>
@@ -26321,7 +26454,21 @@
               <a:buNone/>
             </a:pPr>
             <a:r>
-              <a:rPr lang="en-US" sz="1200" i="1" dirty="0">
+              <a:rPr lang="en-US" sz="1150" b="1" dirty="0">
+                <a:solidFill>
+                  <a:srgbClr val="7A5000"/>
+                </a:solidFill>
+                <a:latin typeface="Calibri" pitchFamily="34" charset="0"/>
+                <a:ea typeface="Calibri" pitchFamily="34" charset="-122"/>
+                <a:cs typeface="Calibri" pitchFamily="34" charset="-120"/>
+              </a:rPr>
+              <a:t>Sentiment: </a:t>
+            </a:r>
+            <a:pPr indent="0" marL="0">
+              <a:buNone/>
+            </a:pPr>
+            <a:r>
+              <a:rPr lang="en-US" sz="1150" dirty="0">
                 <a:solidFill>
                   <a:srgbClr val="5B6475"/>
                 </a:solidFill>
@@ -26329,9 +26476,40 @@
                 <a:ea typeface="Calibri" pitchFamily="34" charset="-122"/>
                 <a:cs typeface="Calibri" pitchFamily="34" charset="-120"/>
               </a:rPr>
-              <a:t>White tags = the 11 product features. Low latency: fast offline checks first; Claude runs only before sensitive actions.</a:t>
-            </a:r>
-            <a:endParaRPr lang="en-US" sz="1200" dirty="0"/>
+              <a:t>Claude scores caller sentiment every turn; two negative turns or an explicit request for a human → Freshdesk ticket.</a:t>
+            </a:r>
+            <a:endParaRPr lang="en-US" sz="1150" dirty="0"/>
+          </a:p>
+          <a:p>
+            <a:pPr indent="0" marL="0">
+              <a:buNone/>
+            </a:pPr>
+            <a:r>
+              <a:rPr lang="en-US" sz="1150" b="1" dirty="0">
+                <a:solidFill>
+                  <a:srgbClr val="2A5C8A"/>
+                </a:solidFill>
+                <a:latin typeface="Calibri" pitchFamily="34" charset="0"/>
+                <a:ea typeface="Calibri" pitchFamily="34" charset="-122"/>
+                <a:cs typeface="Calibri" pitchFamily="34" charset="-120"/>
+              </a:rPr>
+              <a:t>Low latency: </a:t>
+            </a:r>
+            <a:pPr indent="0" marL="0">
+              <a:buNone/>
+            </a:pPr>
+            <a:r>
+              <a:rPr lang="en-US" sz="1150" dirty="0">
+                <a:solidFill>
+                  <a:srgbClr val="5B6475"/>
+                </a:solidFill>
+                <a:latin typeface="Calibri" pitchFamily="34" charset="0"/>
+                <a:ea typeface="Calibri" pitchFamily="34" charset="-122"/>
+                <a:cs typeface="Calibri" pitchFamily="34" charset="-120"/>
+              </a:rPr>
+              <a:t>fast offline checks first (1.87 ms measured); Claude runs only before sensitive actions. White tags = the 11 features.</a:t>
+            </a:r>
+            <a:endParaRPr lang="en-US" sz="1150" dirty="0"/>
           </a:p>
         </p:txBody>
       </p:sp>
@@ -27437,7 +27615,7 @@
                 <a:ea typeface="Calibri" pitchFamily="34" charset="-122"/>
                 <a:cs typeface="Calibri" pitchFamily="34" charset="-120"/>
               </a:rPr>
-              <a:t>Interrupts: the caller can cut in at any time; the agent stops and treats it as the latest input.</a:t>
+              <a:t>Interrupts: VoBiz voice-activity detection stops ElevenLabs playback the moment the caller speaks; the new words become the latest input.</a:t>
             </a:r>
             <a:endParaRPr lang="en-US" sz="1050" dirty="0"/>
           </a:p>

</xml_diff>